<commit_message>
docs(presentation): add authentication note to use case diagram
Store usecase_with_note.png outside LFS and use it on slide 14 of the final deck.

Co-Authored-By: Claude Sonnet 5.5 <noreply@anthropic.com>
Claude-Session: https://claude.ai/code/session_01XqmTXPbZbi3TZHBNcj1kRa
</commit_message>
<xml_diff>
--- a/presentation/technical_defense_final.pptx
+++ b/presentation/technical_defense_final.pptx
@@ -7339,8 +7339,8 @@
         </p:blipFill>
         <p:spPr>
           <a:xfrm>
-            <a:off x="4023360" y="1463040"/>
-            <a:ext cx="3653776" cy="4937760"/>
+            <a:off x="4031918" y="1463040"/>
+            <a:ext cx="3636660" cy="4937760"/>
           </a:xfrm>
           <a:prstGeom prst="rect">
             <a:avLst/>

</xml_diff>